<commit_message>
Swap in real architectural renders for the Girassol placeholders
Replaces the generated placeholder art with the four actual renderings
in both the .pptx and girassol.html, and fixes a flex-direction bug
that was pinning the full-bleed image captions to the top instead of
the bottom of the frame.

Co-Authored-By: Claude Sonnet 5 <noreply@anthropic.com>
Claude-Session: https://claude.ai/code/session_01D3niWHyZbP37SmZDT9iTdu
</commit_message>
<xml_diff>
--- a/assets/girassol/Centro-de-Servicos-Girassol-Cocalzinho.pptx
+++ b/assets/girassol/Centro-de-Servicos-Girassol-Cocalzinho.pptx
@@ -3745,7 +3745,7 @@
       </p:grpSpPr>
       <p:pic>
         <p:nvPicPr>
-          <p:cNvPr id="2" name="Image 0" descr="visuals/reveal-placeholder.png">    </p:cNvPr>
+          <p:cNvPr id="2" name="Image 0" descr="visuals-real/reveal.jpg">    </p:cNvPr>
           <p:cNvPicPr>
             <a:picLocks noChangeAspect="1"/>
           </p:cNvPicPr>
@@ -4874,7 +4874,7 @@
       </p:grpSpPr>
       <p:pic>
         <p:nvPicPr>
-          <p:cNvPr id="2" name="Image 0" descr="visuals/render-placeholder-01.png">    </p:cNvPr>
+          <p:cNvPr id="2" name="Image 0" descr="visuals-real/render-01.jpg">    </p:cNvPr>
           <p:cNvPicPr>
             <a:picLocks noChangeAspect="1"/>
           </p:cNvPicPr>
@@ -5029,7 +5029,7 @@
       </p:grpSpPr>
       <p:pic>
         <p:nvPicPr>
-          <p:cNvPr id="2" name="Image 0" descr="visuals/render-placeholder-02.png">    </p:cNvPr>
+          <p:cNvPr id="2" name="Image 0" descr="visuals-real/render-02.jpg">    </p:cNvPr>
           <p:cNvPicPr>
             <a:picLocks noChangeAspect="1"/>
           </p:cNvPicPr>
@@ -5184,7 +5184,7 @@
       </p:grpSpPr>
       <p:pic>
         <p:nvPicPr>
-          <p:cNvPr id="2" name="Image 0" descr="visuals/render-placeholder-03.png">    </p:cNvPr>
+          <p:cNvPr id="2" name="Image 0" descr="visuals-real/render-03.jpg">    </p:cNvPr>
           <p:cNvPicPr>
             <a:picLocks noChangeAspect="1"/>
           </p:cNvPicPr>
@@ -5339,7 +5339,7 @@
       </p:grpSpPr>
       <p:pic>
         <p:nvPicPr>
-          <p:cNvPr id="2" name="Image 0" descr="visuals/render-placeholder-04.png">    </p:cNvPr>
+          <p:cNvPr id="2" name="Image 0" descr="visuals-real/render-04.jpg">    </p:cNvPr>
           <p:cNvPicPr>
             <a:picLocks noChangeAspect="1"/>
           </p:cNvPicPr>

</xml_diff>

<commit_message>
Note the airport site's direct BR-070 access on the Contexto slide
The planned airport location for Águas Lindas de Goiás already has
direct road access to the BR-070, without cutting through the city's
urban perimeter — strengthens the corridor argument on slide 2.

Co-Authored-By: Claude Sonnet 5 <noreply@anthropic.com>
Claude-Session: https://claude.ai/code/session_01D3niWHyZbP37SmZDT9iTdu
</commit_message>
<xml_diff>
--- a/assets/girassol/Centro-de-Servicos-Girassol-Cocalzinho.pptx
+++ b/assets/girassol/Centro-de-Servicos-Girassol-Cocalzinho.pptx
@@ -1132,7 +1132,7 @@
           <a:p>
             <a:r>
               <a:rPr lang="en-US" dirty="0"/>
-              <a:t>Alguns sinais já são públicos: novo aeroporto em estudo para Águas Lindas, expansão industrial no Entorno, investimentos internacionais mirando a logística regional, e a BR-070 como eixo entre Brasília e o Centro-Oeste. Juntos, esses pontos desenham um corredor — e corredores sempre passam por cidades específicas, nunca por todas. A pergunta é: quem estará preparado?</a:t>
+              <a:t>Alguns sinais já são públicos: o novo aeroporto em estudo para Águas Lindas de Goiás já tem, no local previsto, acesso direto à BR-070 — sem precisar cortar o perímetro urbano da cidade. Some a isso a expansão industrial no Entorno, investimentos internacionais mirando a logística regional, e a própria BR-070 como eixo entre Brasília e o Centro-Oeste. Juntos, esses pontos desenham um corredor — e corredores sempre passam por cidades específicas, nunca por todas. A pergunta é: quem estará preparado?</a:t>
             </a:r>
             <a:endParaRPr lang="en-US" dirty="0"/>
           </a:p>
@@ -4525,7 +4525,7 @@
                 <a:ea typeface="Calibri" pitchFamily="34" charset="-122"/>
                 <a:cs typeface="Calibri" pitchFamily="34" charset="-120"/>
               </a:rPr>
-              <a:t>Novo aeroporto em estudo para Águas Lindas de Goiás</a:t>
+              <a:t>Novo aeroporto em estudo para Águas Lindas de Goiás — local já com acesso direto à BR-070</a:t>
             </a:r>
             <a:endParaRPr lang="en-US" sz="1400" dirty="0"/>
           </a:p>

</xml_diff>

<commit_message>
Simplify the Solução slide wording
Swaps "equipamento urbano de apoio à mobilidade regional" for plain,
direct language — same jargon problem the corridor-economics opening
had, just on the slide explaining what the structure actually is.

Co-Authored-By: Claude Sonnet 5 <noreply@anthropic.com>
Claude-Session: https://claude.ai/code/session_01D3niWHyZbP37SmZDT9iTdu
</commit_message>
<xml_diff>
--- a/assets/girassol/Centro-de-Servicos-Girassol-Cocalzinho.pptx
+++ b/assets/girassol/Centro-de-Servicos-Girassol-Cocalzinho.pptx
@@ -1307,7 +1307,7 @@
           <a:p>
             <a:r>
               <a:rPr lang="en-US" dirty="0"/>
-              <a:t>Oito frentes, uma mesma estrutura: transportadores com apoio real para operar com segurança, agronegócio com um ponto de escoamento mais eficiente, famílias com um lugar preparado para parar — e tudo isso movimentando a economia local e integrando a região.</a:t>
+              <a:t>Não é só abastecer o tanque. É dar suporte de verdade pra quem move a estrada todos os dias: caminhoneiro com onde parar com segurança, produtor com ponto de escoamento, família com estrutura decente pra descansar. Oito frentes, uma estrutura só — e tudo isso movimenta a economia daqui.</a:t>
             </a:r>
             <a:endParaRPr lang="en-US" dirty="0"/>
           </a:p>
@@ -4860,7 +4860,7 @@
                 <a:ea typeface="Cambria" pitchFamily="34" charset="-122"/>
                 <a:cs typeface="Cambria" pitchFamily="34" charset="-120"/>
               </a:rPr>
-              <a:t>Não é um posto de combustíveis.</a:t>
+              <a:t>Muito mais que um posto de combustíveis.</a:t>
             </a:r>
             <a:endParaRPr lang="en-US" sz="2800" dirty="0"/>
           </a:p>
@@ -4899,7 +4899,7 @@
                 <a:ea typeface="Calibri" pitchFamily="34" charset="-122"/>
                 <a:cs typeface="Calibri" pitchFamily="34" charset="-120"/>
               </a:rPr>
-              <a:t>É um equipamento urbano de apoio à mobilidade regional.</a:t>
+              <a:t>Estrutura completa para quem roda a BR-070 todos os dias.</a:t>
             </a:r>
             <a:endParaRPr lang="en-US" sz="1500" dirty="0"/>
           </a:p>

</xml_diff>